<commit_message>
Aggiornata Slide 2 inserendo la comparazione tra Behavioral Cloning e Reinforcement Learning
</commit_message>
<xml_diff>
--- a/documents/presentazione_progetto.pptx
+++ b/documents/presentazione_progetto.pptx
@@ -3269,7 +3269,7 @@
                 </a:solidFill>
                 <a:latin typeface="Arial"/>
               </a:rPr>
-              <a:t>• Apprendimento per Imitazione (Behavioral Cloning):</a:t>
+              <a:t>• Behavioral Cloning (Imitation Learning):</a:t>
             </a:r>
             <a:r>
               <a:rPr sz="1800">
@@ -3278,7 +3278,7 @@
                 </a:solidFill>
                 <a:latin typeface="Arial"/>
               </a:rPr>
-              <a:t> L'agente di guida autonoma impara a condurre l'auto imitando il comportamento di guida di un pilota umano memorizzato in precedenza.</a:t>
+              <a:t> Approccio Supervisionato in cui l'agente apprende direttamente da un dataset di dimostrazioni umane. L'addestramento è immediato, deterministico ed evita il rischio di comportamenti anomali.</a:t>
             </a:r>
           </a:p>
           <a:p>
@@ -3294,7 +3294,7 @@
                 </a:solidFill>
                 <a:latin typeface="Arial"/>
               </a:rPr>
-              <a:t>• Connessione in tempo reale (UDP):</a:t>
+              <a:t>• Reinforcement Learning (RL) - L'Alternativa:</a:t>
             </a:r>
             <a:r>
               <a:rPr sz="1800">
@@ -3303,7 +3303,7 @@
                 </a:solidFill>
                 <a:latin typeface="Arial"/>
               </a:rPr>
-              <a:t> Un client Python dialoga con il simulatore TORCS a 50Hz, inviando input sui pedali e sullo sterzo e ricevendo la telemetria di bordo.</a:t>
+              <a:t> Si basa su tentativi ed errori (trial and error) massimizzando una ricompensa. Richiede tempi lunghissimi di calcolo, simulazioni infinite e un design complesso per la funzione di reward.</a:t>
             </a:r>
           </a:p>
           <a:p>
@@ -3319,7 +3319,7 @@
                 </a:solidFill>
                 <a:latin typeface="Arial"/>
               </a:rPr>
-              <a:t>• Pipeline del Progetto:</a:t>
+              <a:t>• Perché la scelta del Behavioral Cloning:</a:t>
             </a:r>
             <a:r>
               <a:rPr sz="1800">
@@ -3328,10 +3328,7 @@
                 </a:solidFill>
                 <a:latin typeface="Arial"/>
               </a:rPr>
-              <a:t> Articolata in tre passaggi principali:
-  1. Preparazione del dataset (unione e bilanciamento dei giri)
-  2. Addestramento offline del modello K-NN
-  3. Inferenza in tempo reale nel ciclo di guida UDP</a:t>
+              <a:t> Permette di catturare istantaneamente la traiettoria ideale e lo stile di guida del pilota umano, garantendo stabilità immediata sul tracciato ed evitando fasi esplorative distruttive (crash).</a:t>
             </a:r>
           </a:p>
         </p:txBody>

</xml_diff>